<commit_message>
Add Romanian diacritics to all presentation text
Restore proper ă, â, î, ș, ț throughout titles, body, tables and figures
captions (Calibri renders them correctly).

Co-Authored-By: Claude Opus 4.8 <noreply@anthropic.com>
Claude-Session: https://claude.ai/code/session_01TgkBW6yVRwbaPGv2Zh7FsZ
</commit_message>
<xml_diff>
--- a/Prezentare_Licenta_Template.pptx
+++ b/Prezentare_Licenta_Template.pptx
@@ -3328,7 +3328,7 @@
                 </a:solidFill>
                 <a:latin typeface="Calibri"/>
               </a:rPr>
-              <a:t>LUCRARE DE DIPLOMA · 2026</a:t>
+              <a:t>LUCRARE DE DIPLOMĂ · 2026</a:t>
             </a:r>
           </a:p>
         </p:txBody>
@@ -3375,7 +3375,7 @@
                 </a:solidFill>
                 <a:latin typeface="Calibri"/>
               </a:rPr>
-              <a:t>pe retelele sociale</a:t>
+              <a:t>pe rețelele sociale</a:t>
             </a:r>
           </a:p>
         </p:txBody>
@@ -3410,7 +3410,7 @@
                 </a:solidFill>
                 <a:latin typeface="Calibri"/>
               </a:rPr>
-              <a:t>Absolvent: Bianca-Stefania GHEORGHE</a:t>
+              <a:t>Absolvent: Bianca-Ștefania GHEORGHE</a:t>
             </a:r>
           </a:p>
           <a:p>
@@ -3457,7 +3457,7 @@
                 </a:solidFill>
                 <a:latin typeface="Calibri"/>
               </a:rPr>
-              <a:t>Universitatea Nationala de Stiinta si Tehnologie POLITEHNICA Bucuresti · Facultatea Automatica si Calculatoare</a:t>
+              <a:t>Universitatea Națională de Știință și Tehnologie POLITEHNICA București · Facultatea Automatică și Calculatoare</a:t>
             </a:r>
           </a:p>
         </p:txBody>
@@ -3517,7 +3517,7 @@
                 </a:solidFill>
                 <a:latin typeface="Calibri"/>
               </a:rPr>
-              <a:t>Demo aplicatie</a:t>
+              <a:t>Demo aplicație</a:t>
             </a:r>
           </a:p>
         </p:txBody>
@@ -3596,7 +3596,7 @@
                 </a:solidFill>
                 <a:latin typeface="Calibri"/>
               </a:rPr>
-              <a:t>Verdict + scor de risc · evidentiere cuvinte (Leave-One-Out) · comparatie 3 modele · NER · batch CSV</a:t>
+              <a:t>Verdict + scor de risc · evidențiere cuvinte (Leave-One-Out) · comparație 3 modele · NER · batch CSV</a:t>
             </a:r>
           </a:p>
         </p:txBody>
@@ -3827,7 +3827,7 @@
                 </a:solidFill>
                 <a:latin typeface="Calibri"/>
               </a:rPr>
-              <a:t>Dezvoltari viitoare</a:t>
+              <a:t>Dezvoltări viitoare</a:t>
             </a:r>
           </a:p>
         </p:txBody>
@@ -4029,7 +4029,7 @@
                 </a:solidFill>
                 <a:latin typeface="Calibri"/>
               </a:rPr>
-              <a:t>Extindere multilingva</a:t>
+              <a:t>Extindere multilingvă</a:t>
             </a:r>
           </a:p>
         </p:txBody>
@@ -4064,7 +4064,7 @@
                 </a:solidFill>
                 <a:latin typeface="Calibri"/>
               </a:rPr>
-              <a:t>XLM-RoBERTa / seturi dedicate, inclusiv limba romana.</a:t>
+              <a:t>XLM-RoBERTa / seturi dedicate, inclusiv limba română.</a:t>
             </a:r>
           </a:p>
         </p:txBody>
@@ -4187,7 +4187,7 @@
                 </a:solidFill>
                 <a:latin typeface="Calibri"/>
               </a:rPr>
-              <a:t>Reantrenare periodica</a:t>
+              <a:t>Reantrenare periodică</a:t>
             </a:r>
           </a:p>
         </p:txBody>
@@ -4345,7 +4345,7 @@
                 </a:solidFill>
                 <a:latin typeface="Calibri"/>
               </a:rPr>
-              <a:t>Robustete la evitare</a:t>
+              <a:t>Robustețe la evitare</a:t>
             </a:r>
           </a:p>
         </p:txBody>
@@ -4380,7 +4380,7 @@
                 </a:solidFill>
                 <a:latin typeface="Calibri"/>
               </a:rPr>
-              <a:t>Testare impotriva parafrazarii si 'humanizarii'.</a:t>
+              <a:t>Testare împotriva parafrazării și „humanizării”.</a:t>
             </a:r>
           </a:p>
         </p:txBody>
@@ -4538,7 +4538,7 @@
                 </a:solidFill>
                 <a:latin typeface="Calibri"/>
               </a:rPr>
-              <a:t>Metadate de retea: frecventa postare, profil cont.</a:t>
+              <a:t>Metadate de rețea: frecvență postare, profil cont.</a:t>
             </a:r>
           </a:p>
         </p:txBody>
@@ -4661,7 +4661,7 @@
                 </a:solidFill>
                 <a:latin typeface="Calibri"/>
               </a:rPr>
-              <a:t>Infrastructura</a:t>
+              <a:t>Infrastructură</a:t>
             </a:r>
           </a:p>
         </p:txBody>
@@ -4854,7 +4854,7 @@
                 </a:solidFill>
                 <a:latin typeface="Calibri"/>
               </a:rPr>
-              <a:t>Optimizare automata a ponderilor scorului de risc.</a:t>
+              <a:t>Optimizare automată a ponderilor scorului de risc.</a:t>
             </a:r>
           </a:p>
         </p:txBody>
@@ -5259,7 +5259,7 @@
                 </a:solidFill>
                 <a:latin typeface="Calibri"/>
               </a:rPr>
-              <a:t>Va multumesc pentru atentie!</a:t>
+              <a:t>Vă mulțumesc pentru atenție!</a:t>
             </a:r>
           </a:p>
         </p:txBody>
@@ -5294,7 +5294,7 @@
                 </a:solidFill>
                 <a:latin typeface="Calibri"/>
               </a:rPr>
-              <a:t>Detectarea mesajelor generate de AI pe retelele sociale</a:t>
+              <a:t>Detectarea mesajelor generate de AI pe rețelele sociale</a:t>
             </a:r>
           </a:p>
         </p:txBody>
@@ -5329,7 +5329,7 @@
                 </a:solidFill>
                 <a:latin typeface="Calibri"/>
               </a:rPr>
-              <a:t>Bianca-Stefania GHEORGHE · Automatica si Calculatoare · POLITEHNICA Bucuresti · 2026</a:t>
+              <a:t>Bianca-Ștefania GHEORGHE · Automatică și Calculatoare · POLITEHNICA București · 2026</a:t>
             </a:r>
           </a:p>
         </p:txBody>
@@ -5667,7 +5667,7 @@
                 </a:solidFill>
                 <a:latin typeface="Calibri"/>
               </a:rPr>
-              <a:t>Problema si stadiul actual</a:t>
+              <a:t>Problema și stadiul actual</a:t>
             </a:r>
           </a:p>
         </p:txBody>
@@ -5781,7 +5781,7 @@
                 </a:solidFill>
                 <a:latin typeface="Calibri"/>
               </a:rPr>
-              <a:t>Obiective si tehnologii</a:t>
+              <a:t>Obiective și tehnologii</a:t>
             </a:r>
           </a:p>
         </p:txBody>
@@ -6009,7 +6009,7 @@
                 </a:solidFill>
                 <a:latin typeface="Calibri"/>
               </a:rPr>
-              <a:t>Rezultate obtinute</a:t>
+              <a:t>Rezultate obținute</a:t>
             </a:r>
           </a:p>
         </p:txBody>
@@ -6123,7 +6123,7 @@
                 </a:solidFill>
                 <a:latin typeface="Calibri"/>
               </a:rPr>
-              <a:t>Comparatie cu state-of-the-art</a:t>
+              <a:t>Comparație cu state-of-the-art</a:t>
             </a:r>
           </a:p>
         </p:txBody>
@@ -6237,7 +6237,7 @@
                 </a:solidFill>
                 <a:latin typeface="Calibri"/>
               </a:rPr>
-              <a:t>Contributii si demo aplicatie</a:t>
+              <a:t>Contribuții și demo aplicație</a:t>
             </a:r>
           </a:p>
         </p:txBody>
@@ -6297,7 +6297,7 @@
                 </a:solidFill>
                 <a:latin typeface="Calibri"/>
               </a:rPr>
-              <a:t>Problema si stadiul actual</a:t>
+              <a:t>Problema și stadiul actual</a:t>
             </a:r>
           </a:p>
         </p:txBody>
@@ -6438,8 +6438,8 @@
                 </a:solidFill>
                 <a:latin typeface="Calibri"/>
               </a:rPr>
-              <a:t>Retelele sociale = publicare instant, fara filtrare
-→ dezinformare rapida.</a:t>
+              <a:t>Rețelele sociale = publicare instant, fără filtrare
+→ dezinformare rapidă.</a:t>
             </a:r>
           </a:p>
           <a:p>
@@ -6458,8 +6458,8 @@
                 </a:solidFill>
                 <a:latin typeface="Calibri"/>
               </a:rPr>
-              <a:t>Texte scurte si informale: argou, abrevieri, greseli
-→ metodele clasice dau gres.</a:t>
+              <a:t>Texte scurte și informale: argou, abrevieri, greșeli
+→ metodele clasice dau greș.</a:t>
             </a:r>
           </a:p>
           <a:p>
@@ -6479,7 +6479,7 @@
                 <a:latin typeface="Calibri"/>
               </a:rPr>
               <a:t>Instrumentele existente sunt evaluate pe texte
-lungi si formale.</a:t>
+lungi și formale.</a:t>
             </a:r>
           </a:p>
           <a:p>
@@ -6498,7 +6498,7 @@
                 </a:solidFill>
                 <a:latin typeface="Calibri"/>
               </a:rPr>
-              <a:t>Parafrazarea scade acuratetea de la &gt;90% la &lt;50%.</a:t>
+              <a:t>Parafrazarea scade acuratețea de la &gt;90% la &lt;50%.</a:t>
             </a:r>
           </a:p>
         </p:txBody>
@@ -6624,7 +6624,7 @@
                 </a:solidFill>
                 <a:latin typeface="Calibri"/>
               </a:rPr>
-              <a:t>Peisajul metodelor de detectie (pipeline studiat)</a:t>
+              <a:t>Peisajul metodelor de detecție (pipeline studiat)</a:t>
             </a:r>
           </a:p>
         </p:txBody>
@@ -7033,7 +7033,7 @@
                 </a:solidFill>
                 <a:latin typeface="Calibri"/>
               </a:rPr>
-              <a:t>Analiza critica</a:t>
+              <a:t>Analiză critică</a:t>
             </a:r>
           </a:p>
         </p:txBody>
@@ -7068,7 +7068,7 @@
                 </a:solidFill>
                 <a:latin typeface="Calibri"/>
               </a:rPr>
-              <a:t>Metodele existente si limitarile lor pe social media.</a:t>
+              <a:t>Metodele existente și limitările lor pe social media.</a:t>
             </a:r>
           </a:p>
         </p:txBody>
@@ -7270,7 +7270,7 @@
                 </a:solidFill>
                 <a:latin typeface="Calibri"/>
               </a:rPr>
-              <a:t>Solutie specializata</a:t>
+              <a:t>Soluție specializată</a:t>
             </a:r>
           </a:p>
         </p:txBody>
@@ -7507,7 +7507,7 @@
                 </a:solidFill>
                 <a:latin typeface="Calibri"/>
               </a:rPr>
-              <a:t>Comparatie de modele</a:t>
+              <a:t>Comparație de modele</a:t>
             </a:r>
           </a:p>
         </p:txBody>
@@ -7542,7 +7542,7 @@
                 </a:solidFill>
                 <a:latin typeface="Calibri"/>
               </a:rPr>
-              <a:t>3 clasificatori complementari, conditii identice.</a:t>
+              <a:t>3 clasificatori complementari, condiții identice.</a:t>
             </a:r>
           </a:p>
         </p:txBody>
@@ -7744,7 +7744,7 @@
                 </a:solidFill>
                 <a:latin typeface="Calibri"/>
               </a:rPr>
-              <a:t>Aplicatie accesibila</a:t>
+              <a:t>Aplicație accesibilă</a:t>
             </a:r>
           </a:p>
         </p:txBody>
@@ -7779,7 +7779,7 @@
                 </a:solidFill>
                 <a:latin typeface="Calibri"/>
               </a:rPr>
-              <a:t>Interfata web cu justificare transparenta a deciziei.</a:t>
+              <a:t>Interfață web cu justificare transparentă a deciziei.</a:t>
             </a:r>
           </a:p>
         </p:txBody>
@@ -8650,7 +8650,7 @@
                 </a:solidFill>
                 <a:latin typeface="Calibri"/>
               </a:rPr>
-              <a:t>Aplicatie web</a:t>
+              <a:t>Aplicație web</a:t>
             </a:r>
           </a:p>
         </p:txBody>
@@ -8888,7 +8888,7 @@
                 </a:solidFill>
                 <a:latin typeface="Calibri"/>
               </a:rPr>
-              <a:t>Google Colab · GPU NVIDIA Tesla T4 (15.6 GB) · FP16 · RoBERTa ~85 min (3 epoci) · modele clasice &lt;2 min · inferenta CPU 0.5-2 s/text</a:t>
+              <a:t>Google Colab · GPU NVIDIA Tesla T4 (15.6 GB) · FP16 · RoBERTa ~85 min (3 epoci) · modele clasice &lt;2 min · inferență CPU 0.5-2 s/text</a:t>
             </a:r>
           </a:p>
         </p:txBody>
@@ -9388,7 +9388,7 @@
                 </a:solidFill>
                 <a:latin typeface="Calibri"/>
               </a:rPr>
-              <a:t>• 3 modele: Naive Bayes · Reg. Logistica · RoBERTa</a:t>
+              <a:t>• 3 modele: Naive Bayes · Reg. Logistică · RoBERTa</a:t>
             </a:r>
           </a:p>
         </p:txBody>
@@ -9483,7 +9483,7 @@
                 </a:solidFill>
                 <a:latin typeface="Calibri"/>
               </a:rPr>
-              <a:t>Rezultate obtinute</a:t>
+              <a:t>Rezultate obținute</a:t>
             </a:r>
           </a:p>
         </p:txBody>
@@ -9632,7 +9632,7 @@
                 </a:solidFill>
                 <a:latin typeface="Calibri"/>
               </a:rPr>
-              <a:t>Tabel 4.5 — Performanta comparativa</a:t>
+              <a:t>Tabel 4.5 — Performanță comparativă</a:t>
             </a:r>
           </a:p>
         </p:txBody>
@@ -9742,7 +9742,7 @@
                 </a:solidFill>
                 <a:latin typeface="Calibri"/>
               </a:rPr>
-              <a:t>Acuratete</a:t>
+              <a:t>Acuratețe</a:t>
             </a:r>
           </a:p>
         </p:txBody>
@@ -10237,7 +10237,7 @@
                 </a:solidFill>
                 <a:latin typeface="Calibri"/>
               </a:rPr>
-              <a:t>Reg. Logistica</a:t>
+              <a:t>Reg. Logistică</a:t>
             </a:r>
           </a:p>
         </p:txBody>
@@ -10767,7 +10767,7 @@
                 </a:solidFill>
                 <a:latin typeface="Calibri"/>
               </a:rPr>
-              <a:t>RoBERTa depaseste semnificativ modelele clasice:</a:t>
+              <a:t>RoBERTa depășește semnificativ modelele clasice:</a:t>
             </a:r>
           </a:p>
           <a:p>
@@ -10779,7 +10779,7 @@
                 </a:solidFill>
                 <a:latin typeface="Calibri"/>
               </a:rPr>
-              <a:t>+2.5 puncte fata de Reg. Logistica, +5 puncte fata de Naive Bayes.</a:t>
+              <a:t>+2.5 puncte față de Reg. Logistică, +5 puncte față de Naive Bayes.</a:t>
             </a:r>
           </a:p>
         </p:txBody>
@@ -10865,7 +10865,7 @@
                 </a:solidFill>
                 <a:latin typeface="Calibri"/>
               </a:rPr>
-              <a:t>Pe sursele de social media: acuratete &gt; 99.5%</a:t>
+              <a:t>Pe sursele de social media: acuratețe &gt; 99.5%</a:t>
             </a:r>
           </a:p>
           <a:p>
@@ -11066,7 +11066,7 @@
                 </a:solidFill>
                 <a:latin typeface="Calibri"/>
               </a:rPr>
-              <a:t>Mai bine decat state-of-the-art</a:t>
+              <a:t>Mai bine decât state-of-the-art</a:t>
             </a:r>
           </a:p>
         </p:txBody>
@@ -11145,7 +11145,7 @@
                 </a:solidFill>
                 <a:latin typeface="Calibri"/>
               </a:rPr>
-              <a:t>Tabel 5.1 — solutia propusa vs. instrumentele comerciale</a:t>
+              <a:t>Tabel 5.1 — soluția propusă vs. instrumentele comerciale</a:t>
             </a:r>
           </a:p>
         </p:txBody>
@@ -11290,7 +11290,7 @@
                 </a:solidFill>
                 <a:latin typeface="Calibri"/>
               </a:rPr>
-              <a:t>Solutia propusa</a:t>
+              <a:t>Soluția propusă</a:t>
             </a:r>
           </a:p>
         </p:txBody>
@@ -11620,7 +11620,7 @@
                 </a:solidFill>
                 <a:latin typeface="Calibri"/>
               </a:rPr>
-              <a:t>Acuratete (social media)</a:t>
+              <a:t>Acuratețe (social media)</a:t>
             </a:r>
           </a:p>
         </p:txBody>
@@ -12390,7 +12390,7 @@
                 </a:solidFill>
                 <a:latin typeface="Calibri"/>
               </a:rPr>
-              <a:t>Justificare per cuvant</a:t>
+              <a:t>Justificare per cuvânt</a:t>
             </a:r>
           </a:p>
         </p:txBody>
@@ -12775,7 +12775,7 @@
                 </a:solidFill>
                 <a:latin typeface="Calibri"/>
               </a:rPr>
-              <a:t>Comparatie 3 modele</a:t>
+              <a:t>Comparație 3 modele</a:t>
             </a:r>
           </a:p>
         </p:txBody>
@@ -13820,7 +13820,7 @@
                 </a:solidFill>
                 <a:latin typeface="Calibri"/>
               </a:rPr>
-              <a:t>Plata</a:t>
+              <a:t>Plată</a:t>
             </a:r>
           </a:p>
         </p:txBody>
@@ -13930,7 +13930,7 @@
                 </a:solidFill>
                 <a:latin typeface="Calibri"/>
               </a:rPr>
-              <a:t>Transparenta metoda</a:t>
+              <a:t>Transparență metodă</a:t>
             </a:r>
           </a:p>
         </p:txBody>
@@ -14040,7 +14040,7 @@
                 </a:solidFill>
                 <a:latin typeface="Calibri"/>
               </a:rPr>
-              <a:t>Partial</a:t>
+              <a:t>Parțial</a:t>
             </a:r>
           </a:p>
         </p:txBody>
@@ -14150,7 +14150,7 @@
                 </a:solidFill>
                 <a:latin typeface="Calibri"/>
               </a:rPr>
-              <a:t>Partial</a:t>
+              <a:t>Parțial</a:t>
             </a:r>
           </a:p>
         </p:txBody>
@@ -14364,7 +14364,7 @@
                 </a:solidFill>
                 <a:latin typeface="Calibri"/>
               </a:rPr>
-              <a:t>Contributii originale</a:t>
+              <a:t>Contribuții originale</a:t>
             </a:r>
           </a:p>
         </p:txBody>
@@ -14882,7 +14882,7 @@
                 </a:solidFill>
                 <a:latin typeface="Calibri"/>
               </a:rPr>
-              <a:t>Comparatie 3 modele</a:t>
+              <a:t>Comparație 3 modele</a:t>
             </a:r>
           </a:p>
         </p:txBody>
@@ -14917,7 +14917,7 @@
                 </a:solidFill>
                 <a:latin typeface="Calibri"/>
               </a:rPr>
-              <a:t>NB, Reg. Logistica si RoBERTa in conditii identice.</a:t>
+              <a:t>NB, Reg. Logistică și RoBERTa în condiții identice.</a:t>
             </a:r>
           </a:p>
         </p:txBody>
@@ -15154,7 +15154,7 @@
                 </a:solidFill>
                 <a:latin typeface="Calibri"/>
               </a:rPr>
-              <a:t>Explicare la nivel de cuvant — absenta in tool-urile comerciale.</a:t>
+              <a:t>Explicare la nivel de cuvânt — absentă în tool-urile comerciale.</a:t>
             </a:r>
           </a:p>
         </p:txBody>
@@ -15593,7 +15593,7 @@
                 </a:solidFill>
                 <a:latin typeface="Calibri"/>
               </a:rPr>
-              <a:t>Aplicatie web integrata</a:t>
+              <a:t>Aplicație web integrată</a:t>
             </a:r>
           </a:p>
         </p:txBody>
@@ -15628,7 +15628,7 @@
                 </a:solidFill>
                 <a:latin typeface="Calibri"/>
               </a:rPr>
-              <a:t>Analiza, comparatie, NER, per-propozitie, batch CSV — open-source.</a:t>
+              <a:t>Analiză, comparație, NER, per-propoziție, batch CSV — open-source.</a:t>
             </a:r>
           </a:p>
         </p:txBody>

</xml_diff>

<commit_message>
Improve layout of slides 3 (Problema) and 6 (Arhitectura)
Slide 3: bulleted points in an accent card with tight spacing and bullet
markers; pipeline figure enlarged on a clean white card; balanced columns.

Slide 6: remove draw.io grid background from architecture figure; restructure
right panel with a blue header band and key/value rows so text no longer
crowds the bottom edge.

Co-Authored-By: Claude Opus 4.8 <noreply@anthropic.com>
Claude-Session: https://claude.ai/code/session_01TgkBW6yVRwbaPGv2Zh7FsZ
</commit_message>
<xml_diff>
--- a/Prezentare_Licenta_Template.pptx
+++ b/Prezentare_Licenta_Template.pptx
@@ -6383,142 +6383,20 @@
       </p:sp>
       <p:sp>
         <p:nvSpPr>
-          <p:cNvPr id="5" name="TextBox 4"/>
-          <p:cNvSpPr txBox="1"/>
+          <p:cNvPr id="5" name="Rectangle 4"/>
+          <p:cNvSpPr/>
           <p:nvPr/>
         </p:nvSpPr>
         <p:spPr>
           <a:xfrm>
             <a:off x="914400" y="2103120"/>
-            <a:ext cx="6035040" cy="5486400"/>
-          </a:xfrm>
-          <a:prstGeom prst="rect">
-            <a:avLst/>
-          </a:prstGeom>
-          <a:noFill/>
-        </p:spPr>
-        <p:txBody>
-          <a:bodyPr wrap="square">
-            <a:spAutoFit/>
-          </a:bodyPr>
-          <a:lstStyle/>
-          <a:p>
-            <a:pPr>
-              <a:lnSpc>
-                <a:spcPct val="114999"/>
-              </a:lnSpc>
-              <a:spcBef>
-                <a:spcPts val="1400"/>
-              </a:spcBef>
-            </a:pPr>
-            <a:r>
-              <a:rPr sz="1700">
-                <a:solidFill>
-                  <a:srgbClr val="303642"/>
-                </a:solidFill>
-                <a:latin typeface="Calibri"/>
-              </a:rPr>
-              <a:t>LLM-urile (ChatGPT, GPT-4, Gemini) produc texte
-indistinctibile de cele umane.</a:t>
-            </a:r>
-          </a:p>
-          <a:p>
-            <a:pPr>
-              <a:lnSpc>
-                <a:spcPct val="114999"/>
-              </a:lnSpc>
-              <a:spcBef>
-                <a:spcPts val="1400"/>
-              </a:spcBef>
-            </a:pPr>
-            <a:r>
-              <a:rPr sz="1700">
-                <a:solidFill>
-                  <a:srgbClr val="303642"/>
-                </a:solidFill>
-                <a:latin typeface="Calibri"/>
-              </a:rPr>
-              <a:t>Rețelele sociale = publicare instant, fără filtrare
-→ dezinformare rapidă.</a:t>
-            </a:r>
-          </a:p>
-          <a:p>
-            <a:pPr>
-              <a:lnSpc>
-                <a:spcPct val="114999"/>
-              </a:lnSpc>
-              <a:spcBef>
-                <a:spcPts val="1400"/>
-              </a:spcBef>
-            </a:pPr>
-            <a:r>
-              <a:rPr sz="1700">
-                <a:solidFill>
-                  <a:srgbClr val="303642"/>
-                </a:solidFill>
-                <a:latin typeface="Calibri"/>
-              </a:rPr>
-              <a:t>Texte scurte și informale: argou, abrevieri, greșeli
-→ metodele clasice dau greș.</a:t>
-            </a:r>
-          </a:p>
-          <a:p>
-            <a:pPr>
-              <a:lnSpc>
-                <a:spcPct val="114999"/>
-              </a:lnSpc>
-              <a:spcBef>
-                <a:spcPts val="1400"/>
-              </a:spcBef>
-            </a:pPr>
-            <a:r>
-              <a:rPr sz="1700">
-                <a:solidFill>
-                  <a:srgbClr val="303642"/>
-                </a:solidFill>
-                <a:latin typeface="Calibri"/>
-              </a:rPr>
-              <a:t>Instrumentele existente sunt evaluate pe texte
-lungi și formale.</a:t>
-            </a:r>
-          </a:p>
-          <a:p>
-            <a:pPr>
-              <a:lnSpc>
-                <a:spcPct val="114999"/>
-              </a:lnSpc>
-              <a:spcBef>
-                <a:spcPts val="1400"/>
-              </a:spcBef>
-            </a:pPr>
-            <a:r>
-              <a:rPr sz="1700">
-                <a:solidFill>
-                  <a:srgbClr val="303642"/>
-                </a:solidFill>
-                <a:latin typeface="Calibri"/>
-              </a:rPr>
-              <a:t>Parafrazarea scade acuratețea de la &gt;90% la &lt;50%.</a:t>
-            </a:r>
-          </a:p>
-        </p:txBody>
-      </p:sp>
-      <p:sp>
-        <p:nvSpPr>
-          <p:cNvPr id="6" name="Rectangle 5"/>
-          <p:cNvSpPr/>
-          <p:nvPr/>
-        </p:nvSpPr>
-        <p:spPr>
-          <a:xfrm>
-            <a:off x="914400" y="7955279"/>
-            <a:ext cx="6035040" cy="1280160"/>
-          </a:xfrm>
-          <a:prstGeom prst="rect">
-            <a:avLst/>
-          </a:prstGeom>
-          <a:solidFill>
-            <a:srgbClr val="E8F0FB"/>
+            <a:ext cx="6766560" cy="5486400"/>
+          </a:xfrm>
+          <a:prstGeom prst="rect">
+            <a:avLst/>
+          </a:prstGeom>
+          <a:solidFill>
+            <a:srgbClr val="F3F6FB"/>
           </a:solidFill>
           <a:ln>
             <a:noFill/>
@@ -6549,102 +6427,20 @@
       </p:sp>
       <p:sp>
         <p:nvSpPr>
-          <p:cNvPr id="7" name="TextBox 6"/>
-          <p:cNvSpPr txBox="1"/>
-          <p:nvPr/>
-        </p:nvSpPr>
-        <p:spPr>
-          <a:xfrm>
-            <a:off x="1143000" y="8138160"/>
-            <a:ext cx="5577840" cy="914400"/>
-          </a:xfrm>
-          <a:prstGeom prst="rect">
-            <a:avLst/>
-          </a:prstGeom>
-          <a:noFill/>
-        </p:spPr>
-        <p:txBody>
-          <a:bodyPr wrap="square">
-            <a:spAutoFit/>
-          </a:bodyPr>
-          <a:lstStyle/>
-          <a:p>
-            <a:pPr algn="l"/>
-            <a:r>
-              <a:rPr sz="1600" b="1" i="0">
-                <a:solidFill>
-                  <a:srgbClr val="002D7A"/>
-                </a:solidFill>
-                <a:latin typeface="Calibri"/>
-              </a:rPr>
-              <a:t>Niciun instrument comercial nu este optimizat</a:t>
-            </a:r>
-          </a:p>
-          <a:p>
-            <a:pPr algn="l"/>
-            <a:r>
-              <a:rPr sz="1600" b="1" i="0">
-                <a:solidFill>
-                  <a:srgbClr val="002D7A"/>
-                </a:solidFill>
-                <a:latin typeface="Calibri"/>
-              </a:rPr>
-              <a:t>pentru textele scurte de social media.</a:t>
-            </a:r>
-          </a:p>
-        </p:txBody>
-      </p:sp>
-      <p:sp>
-        <p:nvSpPr>
-          <p:cNvPr id="8" name="TextBox 7"/>
-          <p:cNvSpPr txBox="1"/>
-          <p:nvPr/>
-        </p:nvSpPr>
-        <p:spPr>
-          <a:xfrm>
-            <a:off x="7498079" y="2011680"/>
-            <a:ext cx="10058400" cy="457200"/>
-          </a:xfrm>
-          <a:prstGeom prst="rect">
-            <a:avLst/>
-          </a:prstGeom>
-          <a:noFill/>
-        </p:spPr>
-        <p:txBody>
-          <a:bodyPr wrap="square">
-            <a:spAutoFit/>
-          </a:bodyPr>
-          <a:lstStyle/>
-          <a:p>
-            <a:pPr algn="l"/>
-            <a:r>
-              <a:rPr sz="1500" b="0" i="1">
-                <a:solidFill>
-                  <a:srgbClr val="606060"/>
-                </a:solidFill>
-                <a:latin typeface="Calibri"/>
-              </a:rPr>
-              <a:t>Peisajul metodelor de detecție (pipeline studiat)</a:t>
-            </a:r>
-          </a:p>
-        </p:txBody>
-      </p:sp>
-      <p:sp>
-        <p:nvSpPr>
-          <p:cNvPr id="9" name="Rectangle 8"/>
+          <p:cNvPr id="6" name="Rectangle 5"/>
           <p:cNvSpPr/>
           <p:nvPr/>
         </p:nvSpPr>
         <p:spPr>
           <a:xfrm>
-            <a:off x="7150608" y="3339982"/>
-            <a:ext cx="10570464" cy="5024355"/>
-          </a:xfrm>
-          <a:prstGeom prst="rect">
-            <a:avLst/>
-          </a:prstGeom>
-          <a:solidFill>
-            <a:srgbClr val="FFFFFF"/>
+            <a:off x="914400" y="2103120"/>
+            <a:ext cx="201168" cy="5486400"/>
+          </a:xfrm>
+          <a:prstGeom prst="rect">
+            <a:avLst/>
+          </a:prstGeom>
+          <a:solidFill>
+            <a:srgbClr val="004AAD"/>
           </a:solidFill>
           <a:ln>
             <a:noFill/>
@@ -6673,9 +6469,574 @@
           </a:p>
         </p:txBody>
       </p:sp>
+      <p:sp>
+        <p:nvSpPr>
+          <p:cNvPr id="7" name="Rectangle 6"/>
+          <p:cNvSpPr/>
+          <p:nvPr/>
+        </p:nvSpPr>
+        <p:spPr>
+          <a:xfrm>
+            <a:off x="1463040" y="2578608"/>
+            <a:ext cx="146304" cy="146304"/>
+          </a:xfrm>
+          <a:prstGeom prst="rect">
+            <a:avLst/>
+          </a:prstGeom>
+          <a:solidFill>
+            <a:srgbClr val="004AAD"/>
+          </a:solidFill>
+          <a:ln>
+            <a:noFill/>
+          </a:ln>
+          <a:effectLst/>
+        </p:spPr>
+        <p:style>
+          <a:lnRef idx="1">
+            <a:schemeClr val="accent1"/>
+          </a:lnRef>
+          <a:fillRef idx="3">
+            <a:schemeClr val="accent1"/>
+          </a:fillRef>
+          <a:effectRef idx="2">
+            <a:schemeClr val="accent1"/>
+          </a:effectRef>
+          <a:fontRef idx="minor">
+            <a:schemeClr val="lt1"/>
+          </a:fontRef>
+        </p:style>
+        <p:txBody>
+          <a:bodyPr rtlCol="0" anchor="ctr"/>
+          <a:lstStyle/>
+          <a:p>
+            <a:pPr algn="ctr"/>
+          </a:p>
+        </p:txBody>
+      </p:sp>
+      <p:sp>
+        <p:nvSpPr>
+          <p:cNvPr id="8" name="TextBox 7"/>
+          <p:cNvSpPr txBox="1"/>
+          <p:nvPr/>
+        </p:nvSpPr>
+        <p:spPr>
+          <a:xfrm>
+            <a:off x="1828800" y="2468880"/>
+            <a:ext cx="5577840" cy="914400"/>
+          </a:xfrm>
+          <a:prstGeom prst="rect">
+            <a:avLst/>
+          </a:prstGeom>
+          <a:noFill/>
+        </p:spPr>
+        <p:txBody>
+          <a:bodyPr wrap="square">
+            <a:spAutoFit/>
+          </a:bodyPr>
+          <a:lstStyle/>
+          <a:p>
+            <a:pPr algn="l"/>
+            <a:r>
+              <a:rPr sz="1700" b="0" i="0">
+                <a:solidFill>
+                  <a:srgbClr val="303642"/>
+                </a:solidFill>
+                <a:latin typeface="Calibri"/>
+              </a:rPr>
+              <a:t>LLM-urile (ChatGPT, GPT-4, Gemini) produc texte indistinctibile de cele umane.</a:t>
+            </a:r>
+          </a:p>
+        </p:txBody>
+      </p:sp>
+      <p:sp>
+        <p:nvSpPr>
+          <p:cNvPr id="9" name="Rectangle 8"/>
+          <p:cNvSpPr/>
+          <p:nvPr/>
+        </p:nvSpPr>
+        <p:spPr>
+          <a:xfrm>
+            <a:off x="1463040" y="3602736"/>
+            <a:ext cx="146304" cy="146304"/>
+          </a:xfrm>
+          <a:prstGeom prst="rect">
+            <a:avLst/>
+          </a:prstGeom>
+          <a:solidFill>
+            <a:srgbClr val="004AAD"/>
+          </a:solidFill>
+          <a:ln>
+            <a:noFill/>
+          </a:ln>
+          <a:effectLst/>
+        </p:spPr>
+        <p:style>
+          <a:lnRef idx="1">
+            <a:schemeClr val="accent1"/>
+          </a:lnRef>
+          <a:fillRef idx="3">
+            <a:schemeClr val="accent1"/>
+          </a:fillRef>
+          <a:effectRef idx="2">
+            <a:schemeClr val="accent1"/>
+          </a:effectRef>
+          <a:fontRef idx="minor">
+            <a:schemeClr val="lt1"/>
+          </a:fontRef>
+        </p:style>
+        <p:txBody>
+          <a:bodyPr rtlCol="0" anchor="ctr"/>
+          <a:lstStyle/>
+          <a:p>
+            <a:pPr algn="ctr"/>
+          </a:p>
+        </p:txBody>
+      </p:sp>
+      <p:sp>
+        <p:nvSpPr>
+          <p:cNvPr id="10" name="TextBox 9"/>
+          <p:cNvSpPr txBox="1"/>
+          <p:nvPr/>
+        </p:nvSpPr>
+        <p:spPr>
+          <a:xfrm>
+            <a:off x="1828800" y="3493008"/>
+            <a:ext cx="5577840" cy="914400"/>
+          </a:xfrm>
+          <a:prstGeom prst="rect">
+            <a:avLst/>
+          </a:prstGeom>
+          <a:noFill/>
+        </p:spPr>
+        <p:txBody>
+          <a:bodyPr wrap="square">
+            <a:spAutoFit/>
+          </a:bodyPr>
+          <a:lstStyle/>
+          <a:p>
+            <a:pPr algn="l"/>
+            <a:r>
+              <a:rPr sz="1700" b="0" i="0">
+                <a:solidFill>
+                  <a:srgbClr val="303642"/>
+                </a:solidFill>
+                <a:latin typeface="Calibri"/>
+              </a:rPr>
+              <a:t>Rețelele sociale: publicare instant, fără filtrare → dezinformare rapidă.</a:t>
+            </a:r>
+          </a:p>
+        </p:txBody>
+      </p:sp>
+      <p:sp>
+        <p:nvSpPr>
+          <p:cNvPr id="11" name="Rectangle 10"/>
+          <p:cNvSpPr/>
+          <p:nvPr/>
+        </p:nvSpPr>
+        <p:spPr>
+          <a:xfrm>
+            <a:off x="1463040" y="4626864"/>
+            <a:ext cx="146304" cy="146304"/>
+          </a:xfrm>
+          <a:prstGeom prst="rect">
+            <a:avLst/>
+          </a:prstGeom>
+          <a:solidFill>
+            <a:srgbClr val="004AAD"/>
+          </a:solidFill>
+          <a:ln>
+            <a:noFill/>
+          </a:ln>
+          <a:effectLst/>
+        </p:spPr>
+        <p:style>
+          <a:lnRef idx="1">
+            <a:schemeClr val="accent1"/>
+          </a:lnRef>
+          <a:fillRef idx="3">
+            <a:schemeClr val="accent1"/>
+          </a:fillRef>
+          <a:effectRef idx="2">
+            <a:schemeClr val="accent1"/>
+          </a:effectRef>
+          <a:fontRef idx="minor">
+            <a:schemeClr val="lt1"/>
+          </a:fontRef>
+        </p:style>
+        <p:txBody>
+          <a:bodyPr rtlCol="0" anchor="ctr"/>
+          <a:lstStyle/>
+          <a:p>
+            <a:pPr algn="ctr"/>
+          </a:p>
+        </p:txBody>
+      </p:sp>
+      <p:sp>
+        <p:nvSpPr>
+          <p:cNvPr id="12" name="TextBox 11"/>
+          <p:cNvSpPr txBox="1"/>
+          <p:nvPr/>
+        </p:nvSpPr>
+        <p:spPr>
+          <a:xfrm>
+            <a:off x="1828800" y="4517136"/>
+            <a:ext cx="5577840" cy="914400"/>
+          </a:xfrm>
+          <a:prstGeom prst="rect">
+            <a:avLst/>
+          </a:prstGeom>
+          <a:noFill/>
+        </p:spPr>
+        <p:txBody>
+          <a:bodyPr wrap="square">
+            <a:spAutoFit/>
+          </a:bodyPr>
+          <a:lstStyle/>
+          <a:p>
+            <a:pPr algn="l"/>
+            <a:r>
+              <a:rPr sz="1700" b="0" i="0">
+                <a:solidFill>
+                  <a:srgbClr val="303642"/>
+                </a:solidFill>
+                <a:latin typeface="Calibri"/>
+              </a:rPr>
+              <a:t>Texte scurte și informale (argou, abrevieri, greșeli) → metodele clasice dau greș.</a:t>
+            </a:r>
+          </a:p>
+        </p:txBody>
+      </p:sp>
+      <p:sp>
+        <p:nvSpPr>
+          <p:cNvPr id="13" name="Rectangle 12"/>
+          <p:cNvSpPr/>
+          <p:nvPr/>
+        </p:nvSpPr>
+        <p:spPr>
+          <a:xfrm>
+            <a:off x="1463040" y="5650992"/>
+            <a:ext cx="146304" cy="146304"/>
+          </a:xfrm>
+          <a:prstGeom prst="rect">
+            <a:avLst/>
+          </a:prstGeom>
+          <a:solidFill>
+            <a:srgbClr val="004AAD"/>
+          </a:solidFill>
+          <a:ln>
+            <a:noFill/>
+          </a:ln>
+          <a:effectLst/>
+        </p:spPr>
+        <p:style>
+          <a:lnRef idx="1">
+            <a:schemeClr val="accent1"/>
+          </a:lnRef>
+          <a:fillRef idx="3">
+            <a:schemeClr val="accent1"/>
+          </a:fillRef>
+          <a:effectRef idx="2">
+            <a:schemeClr val="accent1"/>
+          </a:effectRef>
+          <a:fontRef idx="minor">
+            <a:schemeClr val="lt1"/>
+          </a:fontRef>
+        </p:style>
+        <p:txBody>
+          <a:bodyPr rtlCol="0" anchor="ctr"/>
+          <a:lstStyle/>
+          <a:p>
+            <a:pPr algn="ctr"/>
+          </a:p>
+        </p:txBody>
+      </p:sp>
+      <p:sp>
+        <p:nvSpPr>
+          <p:cNvPr id="14" name="TextBox 13"/>
+          <p:cNvSpPr txBox="1"/>
+          <p:nvPr/>
+        </p:nvSpPr>
+        <p:spPr>
+          <a:xfrm>
+            <a:off x="1828800" y="5541264"/>
+            <a:ext cx="5577840" cy="914400"/>
+          </a:xfrm>
+          <a:prstGeom prst="rect">
+            <a:avLst/>
+          </a:prstGeom>
+          <a:noFill/>
+        </p:spPr>
+        <p:txBody>
+          <a:bodyPr wrap="square">
+            <a:spAutoFit/>
+          </a:bodyPr>
+          <a:lstStyle/>
+          <a:p>
+            <a:pPr algn="l"/>
+            <a:r>
+              <a:rPr sz="1700" b="0" i="0">
+                <a:solidFill>
+                  <a:srgbClr val="303642"/>
+                </a:solidFill>
+                <a:latin typeface="Calibri"/>
+              </a:rPr>
+              <a:t>Instrumentele existente sunt evaluate pe texte lungi și formale.</a:t>
+            </a:r>
+          </a:p>
+        </p:txBody>
+      </p:sp>
+      <p:sp>
+        <p:nvSpPr>
+          <p:cNvPr id="15" name="Rectangle 14"/>
+          <p:cNvSpPr/>
+          <p:nvPr/>
+        </p:nvSpPr>
+        <p:spPr>
+          <a:xfrm>
+            <a:off x="1463040" y="6675120"/>
+            <a:ext cx="146304" cy="146304"/>
+          </a:xfrm>
+          <a:prstGeom prst="rect">
+            <a:avLst/>
+          </a:prstGeom>
+          <a:solidFill>
+            <a:srgbClr val="004AAD"/>
+          </a:solidFill>
+          <a:ln>
+            <a:noFill/>
+          </a:ln>
+          <a:effectLst/>
+        </p:spPr>
+        <p:style>
+          <a:lnRef idx="1">
+            <a:schemeClr val="accent1"/>
+          </a:lnRef>
+          <a:fillRef idx="3">
+            <a:schemeClr val="accent1"/>
+          </a:fillRef>
+          <a:effectRef idx="2">
+            <a:schemeClr val="accent1"/>
+          </a:effectRef>
+          <a:fontRef idx="minor">
+            <a:schemeClr val="lt1"/>
+          </a:fontRef>
+        </p:style>
+        <p:txBody>
+          <a:bodyPr rtlCol="0" anchor="ctr"/>
+          <a:lstStyle/>
+          <a:p>
+            <a:pPr algn="ctr"/>
+          </a:p>
+        </p:txBody>
+      </p:sp>
+      <p:sp>
+        <p:nvSpPr>
+          <p:cNvPr id="16" name="TextBox 15"/>
+          <p:cNvSpPr txBox="1"/>
+          <p:nvPr/>
+        </p:nvSpPr>
+        <p:spPr>
+          <a:xfrm>
+            <a:off x="1828800" y="6565392"/>
+            <a:ext cx="5577840" cy="914400"/>
+          </a:xfrm>
+          <a:prstGeom prst="rect">
+            <a:avLst/>
+          </a:prstGeom>
+          <a:noFill/>
+        </p:spPr>
+        <p:txBody>
+          <a:bodyPr wrap="square">
+            <a:spAutoFit/>
+          </a:bodyPr>
+          <a:lstStyle/>
+          <a:p>
+            <a:pPr algn="l"/>
+            <a:r>
+              <a:rPr sz="1700" b="0" i="0">
+                <a:solidFill>
+                  <a:srgbClr val="303642"/>
+                </a:solidFill>
+                <a:latin typeface="Calibri"/>
+              </a:rPr>
+              <a:t>Parafrazarea scade acuratețea de la &gt;90% la &lt;50%.</a:t>
+            </a:r>
+          </a:p>
+        </p:txBody>
+      </p:sp>
+      <p:sp>
+        <p:nvSpPr>
+          <p:cNvPr id="17" name="Rectangle 16"/>
+          <p:cNvSpPr/>
+          <p:nvPr/>
+        </p:nvSpPr>
+        <p:spPr>
+          <a:xfrm>
+            <a:off x="914400" y="7955279"/>
+            <a:ext cx="6766560" cy="1325880"/>
+          </a:xfrm>
+          <a:prstGeom prst="rect">
+            <a:avLst/>
+          </a:prstGeom>
+          <a:solidFill>
+            <a:srgbClr val="E8F0FB"/>
+          </a:solidFill>
+          <a:ln>
+            <a:noFill/>
+          </a:ln>
+          <a:effectLst/>
+        </p:spPr>
+        <p:style>
+          <a:lnRef idx="1">
+            <a:schemeClr val="accent1"/>
+          </a:lnRef>
+          <a:fillRef idx="3">
+            <a:schemeClr val="accent1"/>
+          </a:fillRef>
+          <a:effectRef idx="2">
+            <a:schemeClr val="accent1"/>
+          </a:effectRef>
+          <a:fontRef idx="minor">
+            <a:schemeClr val="lt1"/>
+          </a:fontRef>
+        </p:style>
+        <p:txBody>
+          <a:bodyPr rtlCol="0" anchor="ctr"/>
+          <a:lstStyle/>
+          <a:p>
+            <a:pPr algn="ctr"/>
+          </a:p>
+        </p:txBody>
+      </p:sp>
+      <p:sp>
+        <p:nvSpPr>
+          <p:cNvPr id="18" name="TextBox 17"/>
+          <p:cNvSpPr txBox="1"/>
+          <p:nvPr/>
+        </p:nvSpPr>
+        <p:spPr>
+          <a:xfrm>
+            <a:off x="1234440" y="8183879"/>
+            <a:ext cx="6217920" cy="914400"/>
+          </a:xfrm>
+          <a:prstGeom prst="rect">
+            <a:avLst/>
+          </a:prstGeom>
+          <a:noFill/>
+        </p:spPr>
+        <p:txBody>
+          <a:bodyPr wrap="square">
+            <a:spAutoFit/>
+          </a:bodyPr>
+          <a:lstStyle/>
+          <a:p>
+            <a:pPr algn="l"/>
+            <a:r>
+              <a:rPr sz="1700" b="1" i="0">
+                <a:solidFill>
+                  <a:srgbClr val="002D7A"/>
+                </a:solidFill>
+                <a:latin typeface="Calibri"/>
+              </a:rPr>
+              <a:t>Niciun instrument comercial nu este optimizat</a:t>
+            </a:r>
+          </a:p>
+          <a:p>
+            <a:pPr algn="l"/>
+            <a:r>
+              <a:rPr sz="1700" b="1" i="0">
+                <a:solidFill>
+                  <a:srgbClr val="002D7A"/>
+                </a:solidFill>
+                <a:latin typeface="Calibri"/>
+              </a:rPr>
+              <a:t>pentru textele scurte de social media.</a:t>
+            </a:r>
+          </a:p>
+        </p:txBody>
+      </p:sp>
+      <p:sp>
+        <p:nvSpPr>
+          <p:cNvPr id="19" name="TextBox 18"/>
+          <p:cNvSpPr txBox="1"/>
+          <p:nvPr/>
+        </p:nvSpPr>
+        <p:spPr>
+          <a:xfrm>
+            <a:off x="8229600" y="2103120"/>
+            <a:ext cx="9601200" cy="457200"/>
+          </a:xfrm>
+          <a:prstGeom prst="rect">
+            <a:avLst/>
+          </a:prstGeom>
+          <a:noFill/>
+        </p:spPr>
+        <p:txBody>
+          <a:bodyPr wrap="square">
+            <a:spAutoFit/>
+          </a:bodyPr>
+          <a:lstStyle/>
+          <a:p>
+            <a:pPr algn="l"/>
+            <a:r>
+              <a:rPr sz="1500" b="0" i="1">
+                <a:solidFill>
+                  <a:srgbClr val="606060"/>
+                </a:solidFill>
+                <a:latin typeface="Calibri"/>
+              </a:rPr>
+              <a:t>Peisajul metodelor de detecție (pipeline studiat în literatură)</a:t>
+            </a:r>
+          </a:p>
+        </p:txBody>
+      </p:sp>
+      <p:sp>
+        <p:nvSpPr>
+          <p:cNvPr id="20" name="Rectangle 19"/>
+          <p:cNvSpPr/>
+          <p:nvPr/>
+        </p:nvSpPr>
+        <p:spPr>
+          <a:xfrm>
+            <a:off x="8065008" y="3395266"/>
+            <a:ext cx="9930384" cy="4730907"/>
+          </a:xfrm>
+          <a:prstGeom prst="rect">
+            <a:avLst/>
+          </a:prstGeom>
+          <a:solidFill>
+            <a:srgbClr val="FFFFFF"/>
+          </a:solidFill>
+          <a:ln>
+            <a:noFill/>
+          </a:ln>
+          <a:effectLst/>
+        </p:spPr>
+        <p:style>
+          <a:lnRef idx="1">
+            <a:schemeClr val="accent1"/>
+          </a:lnRef>
+          <a:fillRef idx="3">
+            <a:schemeClr val="accent1"/>
+          </a:fillRef>
+          <a:effectRef idx="2">
+            <a:schemeClr val="accent1"/>
+          </a:effectRef>
+          <a:fontRef idx="minor">
+            <a:schemeClr val="lt1"/>
+          </a:fontRef>
+        </p:style>
+        <p:txBody>
+          <a:bodyPr rtlCol="0" anchor="ctr"/>
+          <a:lstStyle/>
+          <a:p>
+            <a:pPr algn="ctr"/>
+          </a:p>
+        </p:txBody>
+      </p:sp>
       <p:pic>
         <p:nvPicPr>
-          <p:cNvPr id="10" name="Picture 9" descr="fig_2_1_pipeline_0.png"/>
+          <p:cNvPr id="21" name="Picture 20" descr="fig_2_1_pipeline_0.png"/>
           <p:cNvPicPr>
             <a:picLocks noChangeAspect="1"/>
           </p:cNvPicPr>
@@ -6689,8 +7050,8 @@
         </p:blipFill>
         <p:spPr>
           <a:xfrm>
-            <a:off x="7315200" y="3504574"/>
-            <a:ext cx="10241280" cy="4695171"/>
+            <a:off x="8229600" y="3559858"/>
+            <a:ext cx="9601200" cy="4401723"/>
           </a:xfrm>
           <a:prstGeom prst="rect">
             <a:avLst/>
@@ -9075,8 +9436,8 @@
         </p:nvSpPr>
         <p:spPr>
           <a:xfrm>
-            <a:off x="2041398" y="2029968"/>
-            <a:ext cx="6615684" cy="8101584"/>
+            <a:off x="1758337" y="2029968"/>
+            <a:ext cx="6541725" cy="8010144"/>
           </a:xfrm>
           <a:prstGeom prst="rect">
             <a:avLst/>
@@ -9113,7 +9474,7 @@
       </p:sp>
       <p:pic>
         <p:nvPicPr>
-          <p:cNvPr id="7" name="Picture 6" descr="fig_3_2_arhitectura_0.png"/>
+          <p:cNvPr id="7" name="Picture 6" descr="fig_3_2_arhitectura_clean.png"/>
           <p:cNvPicPr>
             <a:picLocks noChangeAspect="1"/>
           </p:cNvPicPr>
@@ -9127,8 +9488,8 @@
         </p:blipFill>
         <p:spPr>
           <a:xfrm>
-            <a:off x="2205990" y="2194560"/>
-            <a:ext cx="6286500" cy="7772400"/>
+            <a:off x="1922929" y="2194560"/>
+            <a:ext cx="6212541" cy="7680960"/>
           </a:xfrm>
           <a:prstGeom prst="rect">
             <a:avLst/>
@@ -9143,8 +9504,8 @@
         </p:nvSpPr>
         <p:spPr>
           <a:xfrm>
-            <a:off x="10607040" y="2377440"/>
-            <a:ext cx="7040880" cy="7040880"/>
+            <a:off x="10424160" y="2194560"/>
+            <a:ext cx="7223760" cy="7680960"/>
           </a:xfrm>
           <a:prstGeom prst="rect">
             <a:avLst/>
@@ -9181,84 +9542,14 @@
       </p:sp>
       <p:sp>
         <p:nvSpPr>
-          <p:cNvPr id="9" name="TextBox 8"/>
-          <p:cNvSpPr txBox="1"/>
-          <p:nvPr/>
-        </p:nvSpPr>
-        <p:spPr>
-          <a:xfrm>
-            <a:off x="11064240" y="2651760"/>
-            <a:ext cx="6126480" cy="822960"/>
-          </a:xfrm>
-          <a:prstGeom prst="rect">
-            <a:avLst/>
-          </a:prstGeom>
-          <a:noFill/>
-        </p:spPr>
-        <p:txBody>
-          <a:bodyPr wrap="square">
-            <a:spAutoFit/>
-          </a:bodyPr>
-          <a:lstStyle/>
-          <a:p>
-            <a:pPr algn="ctr"/>
-            <a:r>
-              <a:rPr sz="4000" b="1" i="0">
-                <a:solidFill>
-                  <a:srgbClr val="004AAD"/>
-                </a:solidFill>
-                <a:latin typeface="Calibri"/>
-              </a:rPr>
-              <a:t>45.834 exemple</a:t>
-            </a:r>
-          </a:p>
-        </p:txBody>
-      </p:sp>
-      <p:sp>
-        <p:nvSpPr>
-          <p:cNvPr id="10" name="TextBox 9"/>
-          <p:cNvSpPr txBox="1"/>
-          <p:nvPr/>
-        </p:nvSpPr>
-        <p:spPr>
-          <a:xfrm>
-            <a:off x="11064240" y="3520440"/>
-            <a:ext cx="6126480" cy="457200"/>
-          </a:xfrm>
-          <a:prstGeom prst="rect">
-            <a:avLst/>
-          </a:prstGeom>
-          <a:noFill/>
-        </p:spPr>
-        <p:txBody>
-          <a:bodyPr wrap="square">
-            <a:spAutoFit/>
-          </a:bodyPr>
-          <a:lstStyle/>
-          <a:p>
-            <a:pPr algn="ctr"/>
-            <a:r>
-              <a:rPr sz="1900" b="0" i="0">
-                <a:solidFill>
-                  <a:srgbClr val="303642"/>
-                </a:solidFill>
-                <a:latin typeface="Calibri"/>
-              </a:rPr>
-              <a:t>echilibrate 50/50  uman / AI</a:t>
-            </a:r>
-          </a:p>
-        </p:txBody>
-      </p:sp>
-      <p:sp>
-        <p:nvSpPr>
-          <p:cNvPr id="11" name="Rectangle 10"/>
+          <p:cNvPr id="9" name="Rectangle 8"/>
           <p:cNvSpPr/>
           <p:nvPr/>
         </p:nvSpPr>
         <p:spPr>
           <a:xfrm>
-            <a:off x="11978640" y="4206240"/>
-            <a:ext cx="4297680" cy="25400"/>
+            <a:off x="10424160" y="2194560"/>
+            <a:ext cx="7223760" cy="1371600"/>
           </a:xfrm>
           <a:prstGeom prst="rect">
             <a:avLst/>
@@ -9295,14 +9586,14 @@
       </p:sp>
       <p:sp>
         <p:nvSpPr>
-          <p:cNvPr id="12" name="TextBox 11"/>
+          <p:cNvPr id="10" name="TextBox 9"/>
           <p:cNvSpPr txBox="1"/>
           <p:nvPr/>
         </p:nvSpPr>
         <p:spPr>
           <a:xfrm>
-            <a:off x="11155680" y="4434840"/>
-            <a:ext cx="6035040" cy="2377440"/>
+            <a:off x="10424160" y="2377440"/>
+            <a:ext cx="7223760" cy="822960"/>
           </a:xfrm>
           <a:prstGeom prst="rect">
             <a:avLst/>
@@ -9315,94 +9606,29 @@
           </a:bodyPr>
           <a:lstStyle/>
           <a:p>
-            <a:pPr>
-              <a:lnSpc>
-                <a:spcPct val="130000"/>
-              </a:lnSpc>
-              <a:spcBef>
-                <a:spcPts val="1200"/>
-              </a:spcBef>
-            </a:pPr>
-            <a:r>
-              <a:rPr sz="1700">
-                <a:solidFill>
-                  <a:srgbClr val="303642"/>
-                </a:solidFill>
-                <a:latin typeface="Calibri"/>
-              </a:rPr>
-              <a:t>• Filtrate 50-500 caractere</a:t>
-            </a:r>
-          </a:p>
-          <a:p>
-            <a:pPr>
-              <a:lnSpc>
-                <a:spcPct val="130000"/>
-              </a:lnSpc>
-              <a:spcBef>
-                <a:spcPts val="1200"/>
-              </a:spcBef>
-            </a:pPr>
-            <a:r>
-              <a:rPr sz="1700">
-                <a:solidFill>
-                  <a:srgbClr val="303642"/>
-                </a:solidFill>
-                <a:latin typeface="Calibri"/>
-              </a:rPr>
-              <a:t>• Split stratificat 70 / 15 / 15</a:t>
-            </a:r>
-          </a:p>
-          <a:p>
-            <a:pPr>
-              <a:lnSpc>
-                <a:spcPct val="130000"/>
-              </a:lnSpc>
-              <a:spcBef>
-                <a:spcPts val="1200"/>
-              </a:spcBef>
-            </a:pPr>
-            <a:r>
-              <a:rPr sz="1700">
-                <a:solidFill>
-                  <a:srgbClr val="303642"/>
-                </a:solidFill>
-                <a:latin typeface="Calibri"/>
-              </a:rPr>
-              <a:t>• 6 surse: HC3, TweetEval, Reddit, RAID,
-  AI_Human, AI Detection</a:t>
-            </a:r>
-          </a:p>
-          <a:p>
-            <a:pPr>
-              <a:lnSpc>
-                <a:spcPct val="130000"/>
-              </a:lnSpc>
-              <a:spcBef>
-                <a:spcPts val="1200"/>
-              </a:spcBef>
-            </a:pPr>
-            <a:r>
-              <a:rPr sz="1700">
-                <a:solidFill>
-                  <a:srgbClr val="303642"/>
-                </a:solidFill>
-                <a:latin typeface="Calibri"/>
-              </a:rPr>
-              <a:t>• 3 modele: Naive Bayes · Reg. Logistică · RoBERTa</a:t>
-            </a:r>
-          </a:p>
-        </p:txBody>
-      </p:sp>
-      <p:sp>
-        <p:nvSpPr>
-          <p:cNvPr id="13" name="TextBox 12"/>
+            <a:pPr algn="ctr"/>
+            <a:r>
+              <a:rPr sz="3800" b="1" i="0">
+                <a:solidFill>
+                  <a:srgbClr val="FFFFFF"/>
+                </a:solidFill>
+                <a:latin typeface="Calibri"/>
+              </a:rPr>
+              <a:t>45.834 exemple</a:t>
+            </a:r>
+          </a:p>
+        </p:txBody>
+      </p:sp>
+      <p:sp>
+        <p:nvSpPr>
+          <p:cNvPr id="11" name="TextBox 10"/>
           <p:cNvSpPr txBox="1"/>
           <p:nvPr/>
         </p:nvSpPr>
         <p:spPr>
           <a:xfrm>
-            <a:off x="11064240" y="8686800"/>
-            <a:ext cx="6126480" cy="640080"/>
+            <a:off x="10424160" y="3703320"/>
+            <a:ext cx="7223760" cy="457200"/>
           </a:xfrm>
           <a:prstGeom prst="rect">
             <a:avLst/>
@@ -9417,7 +9643,510 @@
           <a:p>
             <a:pPr algn="ctr"/>
             <a:r>
-              <a:rPr sz="1500" b="0" i="1">
+              <a:rPr sz="2000" b="1" i="0">
+                <a:solidFill>
+                  <a:srgbClr val="002D7A"/>
+                </a:solidFill>
+                <a:latin typeface="Calibri"/>
+              </a:rPr>
+              <a:t>echilibrate 50 / 50  ·  uman / AI</a:t>
+            </a:r>
+          </a:p>
+        </p:txBody>
+      </p:sp>
+      <p:sp>
+        <p:nvSpPr>
+          <p:cNvPr id="12" name="Rectangle 11"/>
+          <p:cNvSpPr/>
+          <p:nvPr/>
+        </p:nvSpPr>
+        <p:spPr>
+          <a:xfrm>
+            <a:off x="10927080" y="4599432"/>
+            <a:ext cx="146304" cy="146304"/>
+          </a:xfrm>
+          <a:prstGeom prst="rect">
+            <a:avLst/>
+          </a:prstGeom>
+          <a:solidFill>
+            <a:srgbClr val="004AAD"/>
+          </a:solidFill>
+          <a:ln>
+            <a:noFill/>
+          </a:ln>
+          <a:effectLst/>
+        </p:spPr>
+        <p:style>
+          <a:lnRef idx="1">
+            <a:schemeClr val="accent1"/>
+          </a:lnRef>
+          <a:fillRef idx="3">
+            <a:schemeClr val="accent1"/>
+          </a:fillRef>
+          <a:effectRef idx="2">
+            <a:schemeClr val="accent1"/>
+          </a:effectRef>
+          <a:fontRef idx="minor">
+            <a:schemeClr val="lt1"/>
+          </a:fontRef>
+        </p:style>
+        <p:txBody>
+          <a:bodyPr rtlCol="0" anchor="ctr"/>
+          <a:lstStyle/>
+          <a:p>
+            <a:pPr algn="ctr"/>
+          </a:p>
+        </p:txBody>
+      </p:sp>
+      <p:sp>
+        <p:nvSpPr>
+          <p:cNvPr id="13" name="TextBox 12"/>
+          <p:cNvSpPr txBox="1"/>
+          <p:nvPr/>
+        </p:nvSpPr>
+        <p:spPr>
+          <a:xfrm>
+            <a:off x="11247120" y="4526280"/>
+            <a:ext cx="6035040" cy="457200"/>
+          </a:xfrm>
+          <a:prstGeom prst="rect">
+            <a:avLst/>
+          </a:prstGeom>
+          <a:noFill/>
+        </p:spPr>
+        <p:txBody>
+          <a:bodyPr wrap="square">
+            <a:spAutoFit/>
+          </a:bodyPr>
+          <a:lstStyle/>
+          <a:p>
+            <a:pPr algn="l"/>
+            <a:r>
+              <a:rPr sz="1700" b="1" i="0">
+                <a:solidFill>
+                  <a:srgbClr val="004AAD"/>
+                </a:solidFill>
+                <a:latin typeface="Calibri"/>
+              </a:rPr>
+              <a:t>Filtrare</a:t>
+            </a:r>
+          </a:p>
+        </p:txBody>
+      </p:sp>
+      <p:sp>
+        <p:nvSpPr>
+          <p:cNvPr id="14" name="TextBox 13"/>
+          <p:cNvSpPr txBox="1"/>
+          <p:nvPr/>
+        </p:nvSpPr>
+        <p:spPr>
+          <a:xfrm>
+            <a:off x="11247120" y="4910328"/>
+            <a:ext cx="6035040" cy="640080"/>
+          </a:xfrm>
+          <a:prstGeom prst="rect">
+            <a:avLst/>
+          </a:prstGeom>
+          <a:noFill/>
+        </p:spPr>
+        <p:txBody>
+          <a:bodyPr wrap="square">
+            <a:spAutoFit/>
+          </a:bodyPr>
+          <a:lstStyle/>
+          <a:p>
+            <a:pPr algn="l"/>
+            <a:r>
+              <a:rPr sz="1500" b="0" i="0">
+                <a:solidFill>
+                  <a:srgbClr val="303642"/>
+                </a:solidFill>
+                <a:latin typeface="Calibri"/>
+              </a:rPr>
+              <a:t>texte de 50-500 caractere</a:t>
+            </a:r>
+          </a:p>
+        </p:txBody>
+      </p:sp>
+      <p:sp>
+        <p:nvSpPr>
+          <p:cNvPr id="15" name="Rectangle 14"/>
+          <p:cNvSpPr/>
+          <p:nvPr/>
+        </p:nvSpPr>
+        <p:spPr>
+          <a:xfrm>
+            <a:off x="10927080" y="5678424"/>
+            <a:ext cx="146304" cy="146304"/>
+          </a:xfrm>
+          <a:prstGeom prst="rect">
+            <a:avLst/>
+          </a:prstGeom>
+          <a:solidFill>
+            <a:srgbClr val="004AAD"/>
+          </a:solidFill>
+          <a:ln>
+            <a:noFill/>
+          </a:ln>
+          <a:effectLst/>
+        </p:spPr>
+        <p:style>
+          <a:lnRef idx="1">
+            <a:schemeClr val="accent1"/>
+          </a:lnRef>
+          <a:fillRef idx="3">
+            <a:schemeClr val="accent1"/>
+          </a:fillRef>
+          <a:effectRef idx="2">
+            <a:schemeClr val="accent1"/>
+          </a:effectRef>
+          <a:fontRef idx="minor">
+            <a:schemeClr val="lt1"/>
+          </a:fontRef>
+        </p:style>
+        <p:txBody>
+          <a:bodyPr rtlCol="0" anchor="ctr"/>
+          <a:lstStyle/>
+          <a:p>
+            <a:pPr algn="ctr"/>
+          </a:p>
+        </p:txBody>
+      </p:sp>
+      <p:sp>
+        <p:nvSpPr>
+          <p:cNvPr id="16" name="TextBox 15"/>
+          <p:cNvSpPr txBox="1"/>
+          <p:nvPr/>
+        </p:nvSpPr>
+        <p:spPr>
+          <a:xfrm>
+            <a:off x="11247120" y="5605272"/>
+            <a:ext cx="6035040" cy="457200"/>
+          </a:xfrm>
+          <a:prstGeom prst="rect">
+            <a:avLst/>
+          </a:prstGeom>
+          <a:noFill/>
+        </p:spPr>
+        <p:txBody>
+          <a:bodyPr wrap="square">
+            <a:spAutoFit/>
+          </a:bodyPr>
+          <a:lstStyle/>
+          <a:p>
+            <a:pPr algn="l"/>
+            <a:r>
+              <a:rPr sz="1700" b="1" i="0">
+                <a:solidFill>
+                  <a:srgbClr val="004AAD"/>
+                </a:solidFill>
+                <a:latin typeface="Calibri"/>
+              </a:rPr>
+              <a:t>Split stratificat</a:t>
+            </a:r>
+          </a:p>
+        </p:txBody>
+      </p:sp>
+      <p:sp>
+        <p:nvSpPr>
+          <p:cNvPr id="17" name="TextBox 16"/>
+          <p:cNvSpPr txBox="1"/>
+          <p:nvPr/>
+        </p:nvSpPr>
+        <p:spPr>
+          <a:xfrm>
+            <a:off x="11247120" y="5989320"/>
+            <a:ext cx="6035040" cy="640080"/>
+          </a:xfrm>
+          <a:prstGeom prst="rect">
+            <a:avLst/>
+          </a:prstGeom>
+          <a:noFill/>
+        </p:spPr>
+        <p:txBody>
+          <a:bodyPr wrap="square">
+            <a:spAutoFit/>
+          </a:bodyPr>
+          <a:lstStyle/>
+          <a:p>
+            <a:pPr algn="l"/>
+            <a:r>
+              <a:rPr sz="1500" b="0" i="0">
+                <a:solidFill>
+                  <a:srgbClr val="303642"/>
+                </a:solidFill>
+                <a:latin typeface="Calibri"/>
+              </a:rPr>
+              <a:t>70 % train · 15 % val · 15 % test</a:t>
+            </a:r>
+          </a:p>
+        </p:txBody>
+      </p:sp>
+      <p:sp>
+        <p:nvSpPr>
+          <p:cNvPr id="18" name="Rectangle 17"/>
+          <p:cNvSpPr/>
+          <p:nvPr/>
+        </p:nvSpPr>
+        <p:spPr>
+          <a:xfrm>
+            <a:off x="10927080" y="6757416"/>
+            <a:ext cx="146304" cy="146304"/>
+          </a:xfrm>
+          <a:prstGeom prst="rect">
+            <a:avLst/>
+          </a:prstGeom>
+          <a:solidFill>
+            <a:srgbClr val="004AAD"/>
+          </a:solidFill>
+          <a:ln>
+            <a:noFill/>
+          </a:ln>
+          <a:effectLst/>
+        </p:spPr>
+        <p:style>
+          <a:lnRef idx="1">
+            <a:schemeClr val="accent1"/>
+          </a:lnRef>
+          <a:fillRef idx="3">
+            <a:schemeClr val="accent1"/>
+          </a:fillRef>
+          <a:effectRef idx="2">
+            <a:schemeClr val="accent1"/>
+          </a:effectRef>
+          <a:fontRef idx="minor">
+            <a:schemeClr val="lt1"/>
+          </a:fontRef>
+        </p:style>
+        <p:txBody>
+          <a:bodyPr rtlCol="0" anchor="ctr"/>
+          <a:lstStyle/>
+          <a:p>
+            <a:pPr algn="ctr"/>
+          </a:p>
+        </p:txBody>
+      </p:sp>
+      <p:sp>
+        <p:nvSpPr>
+          <p:cNvPr id="19" name="TextBox 18"/>
+          <p:cNvSpPr txBox="1"/>
+          <p:nvPr/>
+        </p:nvSpPr>
+        <p:spPr>
+          <a:xfrm>
+            <a:off x="11247120" y="6684264"/>
+            <a:ext cx="6035040" cy="457200"/>
+          </a:xfrm>
+          <a:prstGeom prst="rect">
+            <a:avLst/>
+          </a:prstGeom>
+          <a:noFill/>
+        </p:spPr>
+        <p:txBody>
+          <a:bodyPr wrap="square">
+            <a:spAutoFit/>
+          </a:bodyPr>
+          <a:lstStyle/>
+          <a:p>
+            <a:pPr algn="l"/>
+            <a:r>
+              <a:rPr sz="1700" b="1" i="0">
+                <a:solidFill>
+                  <a:srgbClr val="004AAD"/>
+                </a:solidFill>
+                <a:latin typeface="Calibri"/>
+              </a:rPr>
+              <a:t>6 surse</a:t>
+            </a:r>
+          </a:p>
+        </p:txBody>
+      </p:sp>
+      <p:sp>
+        <p:nvSpPr>
+          <p:cNvPr id="20" name="TextBox 19"/>
+          <p:cNvSpPr txBox="1"/>
+          <p:nvPr/>
+        </p:nvSpPr>
+        <p:spPr>
+          <a:xfrm>
+            <a:off x="11247120" y="7068312"/>
+            <a:ext cx="6035040" cy="640080"/>
+          </a:xfrm>
+          <a:prstGeom prst="rect">
+            <a:avLst/>
+          </a:prstGeom>
+          <a:noFill/>
+        </p:spPr>
+        <p:txBody>
+          <a:bodyPr wrap="square">
+            <a:spAutoFit/>
+          </a:bodyPr>
+          <a:lstStyle/>
+          <a:p>
+            <a:pPr algn="l"/>
+            <a:r>
+              <a:rPr sz="1500" b="0" i="0">
+                <a:solidFill>
+                  <a:srgbClr val="303642"/>
+                </a:solidFill>
+                <a:latin typeface="Calibri"/>
+              </a:rPr>
+              <a:t>HC3, TweetEval, Reddit, RAID,</a:t>
+            </a:r>
+          </a:p>
+          <a:p>
+            <a:pPr algn="l"/>
+            <a:r>
+              <a:rPr sz="1500" b="0" i="0">
+                <a:solidFill>
+                  <a:srgbClr val="303642"/>
+                </a:solidFill>
+                <a:latin typeface="Calibri"/>
+              </a:rPr>
+              <a:t>AI_Human, AI Detection</a:t>
+            </a:r>
+          </a:p>
+        </p:txBody>
+      </p:sp>
+      <p:sp>
+        <p:nvSpPr>
+          <p:cNvPr id="21" name="Rectangle 20"/>
+          <p:cNvSpPr/>
+          <p:nvPr/>
+        </p:nvSpPr>
+        <p:spPr>
+          <a:xfrm>
+            <a:off x="10927080" y="7836408"/>
+            <a:ext cx="146304" cy="146304"/>
+          </a:xfrm>
+          <a:prstGeom prst="rect">
+            <a:avLst/>
+          </a:prstGeom>
+          <a:solidFill>
+            <a:srgbClr val="004AAD"/>
+          </a:solidFill>
+          <a:ln>
+            <a:noFill/>
+          </a:ln>
+          <a:effectLst/>
+        </p:spPr>
+        <p:style>
+          <a:lnRef idx="1">
+            <a:schemeClr val="accent1"/>
+          </a:lnRef>
+          <a:fillRef idx="3">
+            <a:schemeClr val="accent1"/>
+          </a:fillRef>
+          <a:effectRef idx="2">
+            <a:schemeClr val="accent1"/>
+          </a:effectRef>
+          <a:fontRef idx="minor">
+            <a:schemeClr val="lt1"/>
+          </a:fontRef>
+        </p:style>
+        <p:txBody>
+          <a:bodyPr rtlCol="0" anchor="ctr"/>
+          <a:lstStyle/>
+          <a:p>
+            <a:pPr algn="ctr"/>
+          </a:p>
+        </p:txBody>
+      </p:sp>
+      <p:sp>
+        <p:nvSpPr>
+          <p:cNvPr id="22" name="TextBox 21"/>
+          <p:cNvSpPr txBox="1"/>
+          <p:nvPr/>
+        </p:nvSpPr>
+        <p:spPr>
+          <a:xfrm>
+            <a:off x="11247120" y="7763256"/>
+            <a:ext cx="6035040" cy="457200"/>
+          </a:xfrm>
+          <a:prstGeom prst="rect">
+            <a:avLst/>
+          </a:prstGeom>
+          <a:noFill/>
+        </p:spPr>
+        <p:txBody>
+          <a:bodyPr wrap="square">
+            <a:spAutoFit/>
+          </a:bodyPr>
+          <a:lstStyle/>
+          <a:p>
+            <a:pPr algn="l"/>
+            <a:r>
+              <a:rPr sz="1700" b="1" i="0">
+                <a:solidFill>
+                  <a:srgbClr val="004AAD"/>
+                </a:solidFill>
+                <a:latin typeface="Calibri"/>
+              </a:rPr>
+              <a:t>3 modele</a:t>
+            </a:r>
+          </a:p>
+        </p:txBody>
+      </p:sp>
+      <p:sp>
+        <p:nvSpPr>
+          <p:cNvPr id="23" name="TextBox 22"/>
+          <p:cNvSpPr txBox="1"/>
+          <p:nvPr/>
+        </p:nvSpPr>
+        <p:spPr>
+          <a:xfrm>
+            <a:off x="11247120" y="8147304"/>
+            <a:ext cx="6035040" cy="640080"/>
+          </a:xfrm>
+          <a:prstGeom prst="rect">
+            <a:avLst/>
+          </a:prstGeom>
+          <a:noFill/>
+        </p:spPr>
+        <p:txBody>
+          <a:bodyPr wrap="square">
+            <a:spAutoFit/>
+          </a:bodyPr>
+          <a:lstStyle/>
+          <a:p>
+            <a:pPr algn="l"/>
+            <a:r>
+              <a:rPr sz="1500" b="0" i="0">
+                <a:solidFill>
+                  <a:srgbClr val="303642"/>
+                </a:solidFill>
+                <a:latin typeface="Calibri"/>
+              </a:rPr>
+              <a:t>Naive Bayes · Reg. Logistică · RoBERTa</a:t>
+            </a:r>
+          </a:p>
+        </p:txBody>
+      </p:sp>
+      <p:sp>
+        <p:nvSpPr>
+          <p:cNvPr id="24" name="TextBox 23"/>
+          <p:cNvSpPr txBox="1"/>
+          <p:nvPr/>
+        </p:nvSpPr>
+        <p:spPr>
+          <a:xfrm>
+            <a:off x="10927080" y="9098280"/>
+            <a:ext cx="6217920" cy="640080"/>
+          </a:xfrm>
+          <a:prstGeom prst="rect">
+            <a:avLst/>
+          </a:prstGeom>
+          <a:noFill/>
+        </p:spPr>
+        <p:txBody>
+          <a:bodyPr wrap="square">
+            <a:spAutoFit/>
+          </a:bodyPr>
+          <a:lstStyle/>
+          <a:p>
+            <a:pPr algn="ctr"/>
+            <a:r>
+              <a:rPr sz="1400" b="0" i="1">
                 <a:solidFill>
                   <a:srgbClr val="606060"/>
                 </a:solidFill>

</xml_diff>